<commit_message>
Detaylı IQR hesaplamaları rapor ve sunuma eklendi, kod güncellendi
</commit_message>
<xml_diff>
--- a/Gelismis_Analiz_Sunumu.pptx
+++ b/Gelismis_Analiz_Sunumu.pptx
@@ -9,6 +9,7 @@
     <p:sldId id="257" r:id="rId8"/>
     <p:sldId id="258" r:id="rId9"/>
     <p:sldId id="259" r:id="rId10"/>
+    <p:sldId id="260" r:id="rId11"/>
   </p:sldIdLst>
   <p:sldSz cx="9144000" cy="6858000" type="screen4x3"/>
   <p:notesSz cx="6858000" cy="9144000"/>
@@ -3435,6 +3436,103 @@
           </a:prstGeom>
         </p:spPr>
       </p:pic>
+    </p:spTree>
+  </p:cSld>
+  <p:clrMapOvr>
+    <a:masterClrMapping/>
+  </p:clrMapOvr>
+</p:sld>
+</file>
+
+<file path=ppt/slides/slide5.xml><?xml version="1.0" encoding="utf-8"?>
+<p:sld xmlns:a="http://schemas.openxmlformats.org/drawingml/2006/main" xmlns:p="http://schemas.openxmlformats.org/presentationml/2006/main" xmlns:r="http://schemas.openxmlformats.org/officeDocument/2006/relationships">
+  <p:cSld>
+    <p:spTree>
+      <p:nvGrpSpPr>
+        <p:cNvPr id="1" name=""/>
+        <p:cNvGrpSpPr/>
+        <p:nvPr/>
+      </p:nvGrpSpPr>
+      <p:grpSpPr/>
+      <p:sp>
+        <p:nvSpPr>
+          <p:cNvPr id="2" name="Title 1"/>
+          <p:cNvSpPr>
+            <a:spLocks noGrp="1"/>
+          </p:cNvSpPr>
+          <p:nvPr>
+            <p:ph type="title"/>
+          </p:nvPr>
+        </p:nvSpPr>
+        <p:spPr/>
+        <p:txBody>
+          <a:bodyPr/>
+          <a:lstStyle/>
+          <a:p>
+            <a:r>
+              <a:t>Detaylı IQR Hesaplamaları</a:t>
+            </a:r>
+          </a:p>
+        </p:txBody>
+      </p:sp>
+      <p:sp>
+        <p:nvSpPr>
+          <p:cNvPr id="3" name="Content Placeholder 2"/>
+          <p:cNvSpPr>
+            <a:spLocks noGrp="1"/>
+          </p:cNvSpPr>
+          <p:nvPr>
+            <p:ph idx="1"/>
+          </p:nvPr>
+        </p:nvSpPr>
+        <p:spPr/>
+        <p:txBody>
+          <a:bodyPr/>
+          <a:lstStyle/>
+          <a:p>
+            <a:r>
+              <a:t>Aykırı değer tespiti için kullanılan sınırlar:</a:t>
+            </a:r>
+          </a:p>
+          <a:p/>
+          <a:p>
+            <a:r>
+              <a:t>1. Duration (Süre):</a:t>
+            </a:r>
+          </a:p>
+          <a:p>
+            <a:r>
+              <a:t>   - IQR: 9.34 | Üst Sınır: 30.18 | Aykırı: 2,110</a:t>
+            </a:r>
+          </a:p>
+          <a:p>
+            <a:r>
+              <a:t>2. Days Left (Kalan Gün):</a:t>
+            </a:r>
+          </a:p>
+          <a:p>
+            <a:r>
+              <a:t>   - IQR: 23.0 | Üst Sınır: 72.50 | Aykırı: 0</a:t>
+            </a:r>
+          </a:p>
+          <a:p>
+            <a:r>
+              <a:t>3. Price (Fiyat):</a:t>
+            </a:r>
+          </a:p>
+          <a:p>
+            <a:r>
+              <a:t>   - IQR: 37,738 | Üst Sınır: 99,128 | Aykırı: 123</a:t>
+            </a:r>
+          </a:p>
+          <a:p/>
+          <a:p>
+            <a:r>
+              <a:t>Not: Alt sınırlar negatif çıktığı için (fiyat/süre negatif olamaz) sadece üst sınırlar anlamlıdır.</a:t>
+            </a:r>
+          </a:p>
+        </p:txBody>
+      </p:sp>
     </p:spTree>
   </p:cSld>
   <p:clrMapOvr>

</xml_diff>